<commit_message>
Corrige alinhamento e quebras de linha da pagina de status da frente 2
O LibreOffice do ambiente de build estava sem o Impress instalado, entao a
validacao anterior usou so a aproximacao HTML do pptx_preview.py, que
escondia problemas reais de layout. Com o render real corrigido:

- altura das linhas do mini-painel de resultados recalculada (as linhas
  cresciam alem do previsto e desalinhavam os icones sobrepostos)
- coluna "#" mais larga e sem quebra, para "2.1.1" nao virar duas linhas
- colunas Responsavel/Prazo mais largas, sem quebrar os cabecalhos
- fonte do cabecalho da tabela de status reduzida para caber em uma linha

Co-Authored-By: Claude Sonnet 5 <noreply@anthropic.com>
Claude-Session: https://claude.ai/code/session_01EZzU13bGt2JJ9gxFrs8J1n
</commit_message>
<xml_diff>
--- a/output/260925__Status_frente2_resultados.pptx
+++ b/output/260925__Status_frente2_resultados.pptx
@@ -3938,7 +3938,7 @@
         </p:nvGraphicFramePr>
         <p:xfrm>
           <a:off x="384048" y="2148586"/>
-          <a:ext cx="4169706" cy="749808"/>
+          <a:ext cx="4169706" cy="1708023"/>
         </p:xfrm>
         <a:graphic>
           <a:graphicData uri="http://schemas.openxmlformats.org/drawingml/2006/table">
@@ -3957,7 +3957,7 @@
                 <a:gridCol w="364849"/>
                 <a:gridCol w="364849"/>
               </a:tblGrid>
-              <a:tr h="187452">
+              <a:tr h="251841">
                 <a:tc>
                   <a:txBody>
                     <a:bodyPr/>
@@ -4281,7 +4281,7 @@
                   </a:tcPr>
                 </a:tc>
               </a:tr>
-              <a:tr h="187452">
+              <a:tr h="485394">
                 <a:tc>
                   <a:txBody>
                     <a:bodyPr wrap="square"/>
@@ -4663,7 +4663,7 @@
                   </a:tcPr>
                 </a:tc>
               </a:tr>
-              <a:tr h="187452">
+              <a:tr h="485394">
                 <a:tc>
                   <a:txBody>
                     <a:bodyPr wrap="square"/>
@@ -5045,7 +5045,7 @@
                   </a:tcPr>
                 </a:tc>
               </a:tr>
-              <a:tr h="187452">
+              <a:tr h="485394">
                 <a:tc>
                   <a:txBody>
                     <a:bodyPr wrap="square"/>
@@ -5439,7 +5439,7 @@
         </p:nvSpPr>
         <p:spPr>
           <a:xfrm>
-            <a:off x="438912" y="2375082"/>
+            <a:off x="438912" y="2588442"/>
             <a:ext cx="118872" cy="73700"/>
           </a:xfrm>
           <a:prstGeom prst="rect">
@@ -5470,7 +5470,7 @@
         </p:nvSpPr>
         <p:spPr>
           <a:xfrm>
-            <a:off x="454365" y="2391724"/>
+            <a:off x="454365" y="2605084"/>
             <a:ext cx="52303" cy="7726"/>
           </a:xfrm>
           <a:prstGeom prst="rect">
@@ -5500,7 +5500,7 @@
         </p:nvSpPr>
         <p:spPr>
           <a:xfrm>
-            <a:off x="454365" y="2407178"/>
+            <a:off x="454365" y="2620538"/>
             <a:ext cx="87965" cy="7726"/>
           </a:xfrm>
           <a:prstGeom prst="rect">
@@ -5530,7 +5530,7 @@
         </p:nvSpPr>
         <p:spPr>
           <a:xfrm>
-            <a:off x="454365" y="2422631"/>
+            <a:off x="454365" y="2635991"/>
             <a:ext cx="39227" cy="7726"/>
           </a:xfrm>
           <a:prstGeom prst="rect">
@@ -5560,7 +5560,7 @@
         </p:nvSpPr>
         <p:spPr>
           <a:xfrm>
-            <a:off x="490026" y="2448783"/>
+            <a:off x="490026" y="2662143"/>
             <a:ext cx="16642" cy="21396"/>
           </a:xfrm>
           <a:prstGeom prst="rect">
@@ -5590,7 +5590,7 @@
         </p:nvSpPr>
         <p:spPr>
           <a:xfrm>
-            <a:off x="467441" y="2470180"/>
+            <a:off x="467441" y="2683540"/>
             <a:ext cx="61813" cy="10698"/>
           </a:xfrm>
           <a:prstGeom prst="rect">
@@ -5620,7 +5620,7 @@
         </p:nvSpPr>
         <p:spPr>
           <a:xfrm>
-            <a:off x="438912" y="2557780"/>
+            <a:off x="438912" y="3069082"/>
             <a:ext cx="118872" cy="118872"/>
           </a:xfrm>
           <a:prstGeom prst="gear9">
@@ -5650,7 +5650,7 @@
         </p:nvSpPr>
         <p:spPr>
           <a:xfrm>
-            <a:off x="477545" y="2596413"/>
+            <a:off x="477545" y="3107715"/>
             <a:ext cx="41605" cy="41605"/>
           </a:xfrm>
           <a:prstGeom prst="ellipse">
@@ -5680,7 +5680,7 @@
         </p:nvSpPr>
         <p:spPr>
           <a:xfrm rot="20006097">
-            <a:off x="451831" y="2780002"/>
+            <a:off x="451831" y="3589246"/>
             <a:ext cx="93032" cy="7726"/>
           </a:xfrm>
           <a:prstGeom prst="rect">
@@ -5710,7 +5710,7 @@
         </p:nvSpPr>
         <p:spPr>
           <a:xfrm rot="1593903">
-            <a:off x="451831" y="2821607"/>
+            <a:off x="451831" y="3630851"/>
             <a:ext cx="93032" cy="7726"/>
           </a:xfrm>
           <a:prstGeom prst="rect">
@@ -5740,7 +5740,7 @@
         </p:nvSpPr>
         <p:spPr>
           <a:xfrm>
-            <a:off x="438912" y="2786837"/>
+            <a:off x="438912" y="3596081"/>
             <a:ext cx="35661" cy="35661"/>
           </a:xfrm>
           <a:prstGeom prst="ellipse">
@@ -5770,7 +5770,7 @@
         </p:nvSpPr>
         <p:spPr>
           <a:xfrm>
-            <a:off x="522122" y="2745232"/>
+            <a:off x="522122" y="3554476"/>
             <a:ext cx="35661" cy="35661"/>
           </a:xfrm>
           <a:prstGeom prst="ellipse">
@@ -5800,7 +5800,7 @@
         </p:nvSpPr>
         <p:spPr>
           <a:xfrm>
-            <a:off x="522122" y="2828442"/>
+            <a:off x="522122" y="3637686"/>
             <a:ext cx="35661" cy="35661"/>
           </a:xfrm>
           <a:prstGeom prst="ellipse">
@@ -5830,7 +5830,7 @@
         </p:nvSpPr>
         <p:spPr>
           <a:xfrm>
-            <a:off x="384048" y="3044698"/>
+            <a:off x="384048" y="4002913"/>
             <a:ext cx="4169713" cy="146304"/>
           </a:xfrm>
           <a:prstGeom prst="rect">
@@ -5865,7 +5865,7 @@
         </p:nvSpPr>
         <p:spPr>
           <a:xfrm>
-            <a:off x="384048" y="3201035"/>
+            <a:off x="384048" y="4159249"/>
             <a:ext cx="4169713" cy="128016"/>
           </a:xfrm>
           <a:prstGeom prst="rect">
@@ -5901,8 +5901,8 @@
           <p:nvPr/>
         </p:nvGraphicFramePr>
         <p:xfrm>
-          <a:off x="384048" y="3372104"/>
-          <a:ext cx="4169706" cy="562356"/>
+          <a:off x="384048" y="4330319"/>
+          <a:ext cx="4169706" cy="1222629"/>
         </p:xfrm>
         <a:graphic>
           <a:graphicData uri="http://schemas.openxmlformats.org/drawingml/2006/table">
@@ -5921,7 +5921,7 @@
                 <a:gridCol w="364849"/>
                 <a:gridCol w="364849"/>
               </a:tblGrid>
-              <a:tr h="187452">
+              <a:tr h="251841">
                 <a:tc>
                   <a:txBody>
                     <a:bodyPr/>
@@ -6245,7 +6245,7 @@
                   </a:tcPr>
                 </a:tc>
               </a:tr>
-              <a:tr h="187452">
+              <a:tr h="485394">
                 <a:tc>
                   <a:txBody>
                     <a:bodyPr wrap="square"/>
@@ -6588,7 +6588,7 @@
                   </a:tcPr>
                 </a:tc>
               </a:tr>
-              <a:tr h="187452">
+              <a:tr h="485394">
                 <a:tc>
                   <a:txBody>
                     <a:bodyPr wrap="square"/>
@@ -6962,7 +6962,7 @@
         </p:nvSpPr>
         <p:spPr>
           <a:xfrm>
-            <a:off x="441907" y="3637804"/>
+            <a:off x="441907" y="4809379"/>
             <a:ext cx="27958" cy="27958"/>
           </a:xfrm>
           <a:prstGeom prst="ellipse">
@@ -6993,7 +6993,7 @@
         </p:nvSpPr>
         <p:spPr>
           <a:xfrm>
-            <a:off x="438912" y="3663980"/>
+            <a:off x="438912" y="4835555"/>
             <a:ext cx="33949" cy="39940"/>
           </a:xfrm>
           <a:prstGeom prst="round2SameRect">
@@ -7027,7 +7027,7 @@
         </p:nvSpPr>
         <p:spPr>
           <a:xfrm>
-            <a:off x="520363" y="3637804"/>
+            <a:off x="520363" y="4809379"/>
             <a:ext cx="27958" cy="27958"/>
           </a:xfrm>
           <a:prstGeom prst="ellipse">
@@ -7058,7 +7058,7 @@
         </p:nvSpPr>
         <p:spPr>
           <a:xfrm>
-            <a:off x="517367" y="3663980"/>
+            <a:off x="517367" y="4835555"/>
             <a:ext cx="33949" cy="39940"/>
           </a:xfrm>
           <a:prstGeom prst="round2SameRect">
@@ -7092,7 +7092,7 @@
         </p:nvSpPr>
         <p:spPr>
           <a:xfrm>
-            <a:off x="473979" y="3651498"/>
+            <a:off x="473979" y="4823073"/>
             <a:ext cx="48737" cy="55869"/>
           </a:xfrm>
           <a:prstGeom prst="round2SameRect">
@@ -7125,7 +7125,7 @@
         </p:nvSpPr>
         <p:spPr>
           <a:xfrm>
-            <a:off x="477545" y="3619997"/>
+            <a:off x="477545" y="4791572"/>
             <a:ext cx="41605" cy="41605"/>
           </a:xfrm>
           <a:prstGeom prst="ellipse">
@@ -7155,7 +7155,7 @@
         </p:nvSpPr>
         <p:spPr>
           <a:xfrm>
-            <a:off x="481705" y="3624158"/>
+            <a:off x="481705" y="4795733"/>
             <a:ext cx="33284" cy="33284"/>
           </a:xfrm>
           <a:prstGeom prst="ellipse">
@@ -7186,7 +7186,7 @@
         </p:nvSpPr>
         <p:spPr>
           <a:xfrm>
-            <a:off x="478139" y="3655659"/>
+            <a:off x="478139" y="4827234"/>
             <a:ext cx="40416" cy="47548"/>
           </a:xfrm>
           <a:prstGeom prst="round2SameRect">
@@ -7220,7 +7220,7 @@
         </p:nvSpPr>
         <p:spPr>
           <a:xfrm>
-            <a:off x="438912" y="3781298"/>
+            <a:off x="438912" y="5250815"/>
             <a:ext cx="118872" cy="118872"/>
           </a:xfrm>
           <a:prstGeom prst="donut">
@@ -7252,7 +7252,7 @@
         </p:nvSpPr>
         <p:spPr>
           <a:xfrm>
-            <a:off x="468629" y="3811015"/>
+            <a:off x="468629" y="5280533"/>
             <a:ext cx="59436" cy="59436"/>
           </a:xfrm>
           <a:prstGeom prst="donut">
@@ -7284,7 +7284,7 @@
         </p:nvSpPr>
         <p:spPr>
           <a:xfrm>
-            <a:off x="486460" y="3828846"/>
+            <a:off x="486460" y="5298363"/>
             <a:ext cx="23774" cy="23774"/>
           </a:xfrm>
           <a:prstGeom prst="ellipse">
@@ -7413,7 +7413,7 @@
         </p:nvGraphicFramePr>
         <p:xfrm>
           <a:off x="4718353" y="1821180"/>
-          <a:ext cx="7089565" cy="4945380"/>
+          <a:ext cx="7089564" cy="4945380"/>
         </p:xfrm>
         <a:graphic>
           <a:graphicData uri="http://schemas.openxmlformats.org/drawingml/2006/table">
@@ -7422,14 +7422,14 @@
                 <a:tableStyleId>{2D5ABB26-0587-4C30-8999-92F81FD0307C}</a:tableStyleId>
               </a:tblPr>
               <a:tblGrid>
-                <a:gridCol w="309523"/>
-                <a:gridCol w="1437074"/>
-                <a:gridCol w="773809"/>
-                <a:gridCol w="405328"/>
-                <a:gridCol w="736961"/>
-                <a:gridCol w="1142290"/>
-                <a:gridCol w="1142290"/>
-                <a:gridCol w="1142290"/>
+                <a:gridCol w="387986"/>
+                <a:gridCol w="1199230"/>
+                <a:gridCol w="917058"/>
+                <a:gridCol w="493800"/>
+                <a:gridCol w="705429"/>
+                <a:gridCol w="1128687"/>
+                <a:gridCol w="1128687"/>
+                <a:gridCol w="1128687"/>
               </a:tblGrid>
               <a:tr h="256032">
                 <a:tc>
@@ -7439,7 +7439,7 @@
                     <a:p>
                       <a:pPr algn="l"/>
                       <a:r>
-                        <a:rPr sz="750" b="1" i="0" lang="pt-BR">
+                        <a:rPr sz="650" b="1" i="0" lang="pt-BR">
                           <a:solidFill>
                             <a:srgbClr val="757575"/>
                           </a:solidFill>
@@ -7476,7 +7476,7 @@
                     <a:p>
                       <a:pPr algn="l"/>
                       <a:r>
-                        <a:rPr sz="750" b="1" i="0" lang="pt-BR">
+                        <a:rPr sz="650" b="1" i="0" lang="pt-BR">
                           <a:solidFill>
                             <a:srgbClr val="757575"/>
                           </a:solidFill>
@@ -7513,7 +7513,7 @@
                     <a:p>
                       <a:pPr algn="l"/>
                       <a:r>
-                        <a:rPr sz="750" b="1" i="0" lang="pt-BR">
+                        <a:rPr sz="650" b="1" i="0" lang="pt-BR">
                           <a:solidFill>
                             <a:srgbClr val="757575"/>
                           </a:solidFill>
@@ -7550,7 +7550,7 @@
                     <a:p>
                       <a:pPr algn="l"/>
                       <a:r>
-                        <a:rPr sz="750" b="1" i="0" lang="pt-BR">
+                        <a:rPr sz="650" b="1" i="0" lang="pt-BR">
                           <a:solidFill>
                             <a:srgbClr val="757575"/>
                           </a:solidFill>
@@ -7587,7 +7587,7 @@
                     <a:p>
                       <a:pPr algn="ctr"/>
                       <a:r>
-                        <a:rPr sz="750" b="1" i="0" lang="pt-BR">
+                        <a:rPr sz="650" b="1" i="0" lang="pt-BR">
                           <a:solidFill>
                             <a:srgbClr val="757575"/>
                           </a:solidFill>
@@ -7624,7 +7624,7 @@
                     <a:p>
                       <a:pPr algn="l"/>
                       <a:r>
-                        <a:rPr sz="750" b="1" i="0" lang="pt-BR">
+                        <a:rPr sz="650" b="1" i="0" lang="pt-BR">
                           <a:solidFill>
                             <a:srgbClr val="757575"/>
                           </a:solidFill>
@@ -7661,7 +7661,7 @@
                     <a:p>
                       <a:pPr algn="l"/>
                       <a:r>
-                        <a:rPr sz="750" b="1" i="0" lang="pt-BR">
+                        <a:rPr sz="650" b="1" i="0" lang="pt-BR">
                           <a:solidFill>
                             <a:srgbClr val="757575"/>
                           </a:solidFill>
@@ -7698,7 +7698,7 @@
                     <a:p>
                       <a:pPr algn="l"/>
                       <a:r>
-                        <a:rPr sz="750" b="1" i="0" lang="pt-BR">
+                        <a:rPr sz="650" b="1" i="0" lang="pt-BR">
                           <a:solidFill>
                             <a:srgbClr val="757575"/>
                           </a:solidFill>
@@ -7729,10 +7729,10 @@
                   </a:tcPr>
                 </a:tc>
               </a:tr>
-              <a:tr h="944118">
-                <a:tc>
-                  <a:txBody>
-                    <a:bodyPr wrap="square"/>
+              <a:tr h="883158">
+                <a:tc>
+                  <a:txBody>
+                    <a:bodyPr wrap="none"/>
                     <a:lstStyle/>
                     <a:p>
                       <a:pPr algn="l"/>
@@ -8109,10 +8109,10 @@
                   </a:tcPr>
                 </a:tc>
               </a:tr>
-              <a:tr h="822198">
-                <a:tc>
-                  <a:txBody>
-                    <a:bodyPr wrap="square"/>
+              <a:tr h="761238">
+                <a:tc>
+                  <a:txBody>
+                    <a:bodyPr wrap="none"/>
                     <a:lstStyle/>
                     <a:p>
                       <a:pPr algn="l"/>
@@ -8424,10 +8424,10 @@
                   </a:tcPr>
                 </a:tc>
               </a:tr>
-              <a:tr h="822198">
-                <a:tc>
-                  <a:txBody>
-                    <a:bodyPr wrap="square"/>
+              <a:tr h="761238">
+                <a:tc>
+                  <a:txBody>
+                    <a:bodyPr wrap="none"/>
                     <a:lstStyle/>
                     <a:p>
                       <a:pPr algn="l"/>
@@ -8748,10 +8748,10 @@
                   </a:tcPr>
                 </a:tc>
               </a:tr>
-              <a:tr h="578358">
-                <a:tc>
-                  <a:txBody>
-                    <a:bodyPr wrap="square"/>
+              <a:tr h="517398">
+                <a:tc>
+                  <a:txBody>
+                    <a:bodyPr wrap="none"/>
                     <a:lstStyle/>
                     <a:p>
                       <a:pPr algn="l"/>
@@ -9054,10 +9054,10 @@
                   </a:tcPr>
                 </a:tc>
               </a:tr>
-              <a:tr h="822198">
-                <a:tc>
-                  <a:txBody>
-                    <a:bodyPr wrap="square"/>
+              <a:tr h="883158">
+                <a:tc>
+                  <a:txBody>
+                    <a:bodyPr wrap="none"/>
                     <a:lstStyle/>
                     <a:p>
                       <a:pPr algn="l"/>
@@ -9415,10 +9415,10 @@
                   </a:tcPr>
                 </a:tc>
               </a:tr>
-              <a:tr h="700278">
-                <a:tc>
-                  <a:txBody>
-                    <a:bodyPr wrap="square"/>
+              <a:tr h="883158">
+                <a:tc>
+                  <a:txBody>
+                    <a:bodyPr wrap="none"/>
                     <a:lstStyle/>
                     <a:p>
                       <a:pPr algn="l"/>
@@ -9733,7 +9733,7 @@
         </p:nvSpPr>
         <p:spPr>
           <a:xfrm>
-            <a:off x="4799963" y="2820162"/>
+            <a:off x="4839194" y="2759202"/>
             <a:ext cx="146304" cy="146304"/>
           </a:xfrm>
           <a:prstGeom prst="ellipse">
@@ -9772,7 +9772,7 @@
         </p:nvSpPr>
         <p:spPr>
           <a:xfrm>
-            <a:off x="4708523" y="3642360"/>
+            <a:off x="4747754" y="3520440"/>
             <a:ext cx="146304" cy="146304"/>
           </a:xfrm>
           <a:prstGeom prst="ellipse">
@@ -9811,7 +9811,7 @@
         </p:nvSpPr>
         <p:spPr>
           <a:xfrm>
-            <a:off x="4891403" y="3642360"/>
+            <a:off x="4930634" y="3520440"/>
             <a:ext cx="146304" cy="146304"/>
           </a:xfrm>
           <a:prstGeom prst="ellipse">
@@ -9850,7 +9850,7 @@
         </p:nvSpPr>
         <p:spPr>
           <a:xfrm>
-            <a:off x="4799963" y="4464558"/>
+            <a:off x="4839194" y="4281678"/>
             <a:ext cx="146304" cy="146304"/>
           </a:xfrm>
           <a:prstGeom prst="ellipse">
@@ -9889,7 +9889,7 @@
         </p:nvSpPr>
         <p:spPr>
           <a:xfrm>
-            <a:off x="4799963" y="5042916"/>
+            <a:off x="4839194" y="4799076"/>
             <a:ext cx="146304" cy="146304"/>
           </a:xfrm>
           <a:prstGeom prst="ellipse">

</xml_diff>

<commit_message>
Icones proprios para Liza/Chatbot e cores mais fieis ao print original
- Liza e Chatbot ganham distintivos circulares desenhados na mao (robo e
  balao de fala em branco sobre azul), em vez dos icones genericos de
  icons_bain.py que nao lembravam nada os do print
- Leads Classif. passa a usar pessoas_cheio (preenchido), mais perto do
  icone do print do que a versao so-contorno
- paleta do heatmap de "Qualidade dos leads" mais suave/esmaecida, batendo
  com os tons pastel observados no print (amostrados pixel a pixel)

Co-Authored-By: Claude Sonnet 5 <noreply@anthropic.com>
Claude-Session: https://claude.ai/code/session_01EZzU13bGt2JJ9gxFrs8J1n
</commit_message>
<xml_diff>
--- a/output/260925__Status_frente2_resultados.pptx
+++ b/output/260925__Status_frente2_resultados.pptx
@@ -4525,7 +4525,7 @@
                       </a:r>
                     </a:p>
                   </a:txBody>
-                  <a:tcPr marL="219456" marR="219456" marT="36576" marB="36576" anchor="ctr">
+                  <a:tcPr marL="256032" marR="256032" marT="36576" marB="36576" anchor="ctr">
                     <a:lnL w="6350" cap="flat" cmpd="sng" algn="ctr">
                       <a:noFill/>
                     </a:lnL>
@@ -4628,7 +4628,7 @@
                       <a:r>
                         <a:rPr sz="800" b="1" i="0" lang="pt-BR">
                           <a:solidFill>
-                            <a:srgbClr val="616300"/>
+                            <a:srgbClr val="787C12"/>
                           </a:solidFill>
                           <a:latin typeface="Arial"/>
                         </a:rPr>
@@ -4656,7 +4656,7 @@
                       </a:solidFill>
                     </a:lnB>
                     <a:solidFill>
-                      <a:srgbClr val="E9ECAE"/>
+                      <a:srgbClr val="E9E9CA"/>
                     </a:solidFill>
                   </a:tcPr>
                 </a:tc>
@@ -4669,7 +4669,7 @@
                       <a:r>
                         <a:rPr sz="800" b="1" i="0" lang="pt-BR">
                           <a:solidFill>
-                            <a:srgbClr val="616300"/>
+                            <a:srgbClr val="787C12"/>
                           </a:solidFill>
                           <a:latin typeface="Arial"/>
                         </a:rPr>
@@ -4697,7 +4697,7 @@
                       </a:solidFill>
                     </a:lnB>
                     <a:solidFill>
-                      <a:srgbClr val="E9ECAE"/>
+                      <a:srgbClr val="E9E9CA"/>
                     </a:solidFill>
                   </a:tcPr>
                 </a:tc>
@@ -4710,7 +4710,7 @@
                       <a:r>
                         <a:rPr sz="800" b="1" i="0" lang="pt-BR">
                           <a:solidFill>
-                            <a:srgbClr val="5A6300"/>
+                            <a:srgbClr val="737C15"/>
                           </a:solidFill>
                           <a:latin typeface="Arial"/>
                         </a:rPr>
@@ -4738,7 +4738,7 @@
                       </a:solidFill>
                     </a:lnB>
                     <a:solidFill>
-                      <a:srgbClr val="E6ECB1"/>
+                      <a:srgbClr val="E8E9CB"/>
                     </a:solidFill>
                   </a:tcPr>
                 </a:tc>
@@ -4751,7 +4751,7 @@
                       <a:r>
                         <a:rPr sz="800" b="1" i="0" lang="pt-BR">
                           <a:solidFill>
-                            <a:srgbClr val="536300"/>
+                            <a:srgbClr val="6E7C17"/>
                           </a:solidFill>
                           <a:latin typeface="Arial"/>
                         </a:rPr>
@@ -4779,7 +4779,7 @@
                       </a:solidFill>
                     </a:lnB>
                     <a:solidFill>
-                      <a:srgbClr val="E4ECB3"/>
+                      <a:srgbClr val="E6E9CB"/>
                     </a:solidFill>
                   </a:tcPr>
                 </a:tc>
@@ -4792,7 +4792,7 @@
                       <a:r>
                         <a:rPr sz="800" b="1" i="0" lang="pt-BR">
                           <a:solidFill>
-                            <a:srgbClr val="146100"/>
+                            <a:srgbClr val="3E7C2B"/>
                           </a:solidFill>
                           <a:latin typeface="Arial"/>
                         </a:rPr>
@@ -4820,7 +4820,7 @@
                       </a:solidFill>
                     </a:lnB>
                     <a:solidFill>
-                      <a:srgbClr val="CDEEC7"/>
+                      <a:srgbClr val="D8E9CF"/>
                     </a:solidFill>
                   </a:tcPr>
                 </a:tc>
@@ -4833,7 +4833,7 @@
                       <a:r>
                         <a:rPr sz="800" b="1" i="0" lang="pt-BR">
                           <a:solidFill>
-                            <a:srgbClr val="006100"/>
+                            <a:srgbClr val="2E7D32"/>
                           </a:solidFill>
                           <a:latin typeface="Arial"/>
                         </a:rPr>
@@ -4861,7 +4861,7 @@
                       </a:solidFill>
                     </a:lnB>
                     <a:solidFill>
-                      <a:srgbClr val="C6EFCE"/>
+                      <a:srgbClr val="D4E9D1"/>
                     </a:solidFill>
                   </a:tcPr>
                 </a:tc>
@@ -4907,7 +4907,7 @@
                       </a:r>
                     </a:p>
                   </a:txBody>
-                  <a:tcPr marL="219456" marR="219456" marT="36576" marB="36576" anchor="ctr">
+                  <a:tcPr marL="256032" marR="256032" marT="36576" marB="36576" anchor="ctr">
                     <a:lnL w="6350" cap="flat" cmpd="sng" algn="ctr">
                       <a:noFill/>
                     </a:lnL>
@@ -5010,7 +5010,7 @@
                       <a:r>
                         <a:rPr sz="800" b="1" i="0" lang="pt-BR">
                           <a:solidFill>
-                            <a:srgbClr val="226100"/>
+                            <a:srgbClr val="487C26"/>
                           </a:solidFill>
                           <a:latin typeface="Arial"/>
                         </a:rPr>
@@ -5038,7 +5038,7 @@
                       </a:solidFill>
                     </a:lnB>
                     <a:solidFill>
-                      <a:srgbClr val="D2EEC2"/>
+                      <a:srgbClr val="DBE9CE"/>
                     </a:solidFill>
                   </a:tcPr>
                 </a:tc>
@@ -5051,7 +5051,7 @@
                       <a:r>
                         <a:rPr sz="800" b="1" i="0" lang="pt-BR">
                           <a:solidFill>
-                            <a:srgbClr val="9C2803"/>
+                            <a:srgbClr val="AC4A21"/>
                           </a:solidFill>
                           <a:latin typeface="Arial"/>
                         </a:rPr>
@@ -5079,7 +5079,7 @@
                       </a:solidFill>
                     </a:lnB>
                     <a:solidFill>
-                      <a:srgbClr val="FFD5BA"/>
+                      <a:srgbClr val="F6D6C9"/>
                     </a:solidFill>
                   </a:tcPr>
                 </a:tc>
@@ -5092,7 +5092,7 @@
                       <a:r>
                         <a:rPr sz="800" b="1" i="0" lang="pt-BR">
                           <a:solidFill>
-                            <a:srgbClr val="9C3E02"/>
+                            <a:srgbClr val="A95D14"/>
                           </a:solidFill>
                           <a:latin typeface="Arial"/>
                         </a:rPr>
@@ -5120,7 +5120,7 @@
                       </a:solidFill>
                     </a:lnB>
                     <a:solidFill>
-                      <a:srgbClr val="FFDDAE"/>
+                      <a:srgbClr val="F6DDC8"/>
                     </a:solidFill>
                   </a:tcPr>
                 </a:tc>
@@ -5133,7 +5133,7 @@
                       <a:r>
                         <a:rPr sz="800" b="1" i="0" lang="pt-BR">
                           <a:solidFill>
-                            <a:srgbClr val="8A6400"/>
+                            <a:srgbClr val="987C05"/>
                           </a:solidFill>
                           <a:latin typeface="Arial"/>
                         </a:rPr>
@@ -5161,7 +5161,7 @@
                       </a:solidFill>
                     </a:lnB>
                     <a:solidFill>
-                      <a:srgbClr val="F8EBA1"/>
+                      <a:srgbClr val="F3E9C8"/>
                     </a:solidFill>
                   </a:tcPr>
                 </a:tc>
@@ -5174,7 +5174,7 @@
                       <a:r>
                         <a:rPr sz="800" b="1" i="0" lang="pt-BR">
                           <a:solidFill>
-                            <a:srgbClr val="006100"/>
+                            <a:srgbClr val="2E7D32"/>
                           </a:solidFill>
                           <a:latin typeface="Arial"/>
                         </a:rPr>
@@ -5202,7 +5202,7 @@
                       </a:solidFill>
                     </a:lnB>
                     <a:solidFill>
-                      <a:srgbClr val="C6EFCE"/>
+                      <a:srgbClr val="D4E9D1"/>
                     </a:solidFill>
                   </a:tcPr>
                 </a:tc>
@@ -5215,7 +5215,7 @@
                       <a:r>
                         <a:rPr sz="800" b="1" i="0" lang="pt-BR">
                           <a:solidFill>
-                            <a:srgbClr val="146100"/>
+                            <a:srgbClr val="3E7C2B"/>
                           </a:solidFill>
                           <a:latin typeface="Arial"/>
                         </a:rPr>
@@ -5243,7 +5243,7 @@
                       </a:solidFill>
                     </a:lnB>
                     <a:solidFill>
-                      <a:srgbClr val="CDEEC7"/>
+                      <a:srgbClr val="D8E9CF"/>
                     </a:solidFill>
                   </a:tcPr>
                 </a:tc>
@@ -5289,7 +5289,7 @@
                       </a:r>
                     </a:p>
                   </a:txBody>
-                  <a:tcPr marL="219456" marR="219456" marT="36576" marB="36576" anchor="ctr">
+                  <a:tcPr marL="256032" marR="256032" marT="36576" marB="36576" anchor="ctr">
                     <a:lnL w="6350" cap="flat" cmpd="sng" algn="ctr">
                       <a:noFill/>
                     </a:lnL>
@@ -5392,7 +5392,7 @@
                       <a:r>
                         <a:rPr sz="800" b="1" i="0" lang="pt-BR">
                           <a:solidFill>
-                            <a:srgbClr val="9C3502"/>
+                            <a:srgbClr val="AA5519"/>
                           </a:solidFill>
                           <a:latin typeface="Arial"/>
                         </a:rPr>
@@ -5420,7 +5420,7 @@
                       </a:solidFill>
                     </a:lnB>
                     <a:solidFill>
-                      <a:srgbClr val="FFDAB3"/>
+                      <a:srgbClr val="F6DAC8"/>
                     </a:solidFill>
                   </a:tcPr>
                 </a:tc>
@@ -5433,7 +5433,7 @@
                       <a:r>
                         <a:rPr sz="800" b="1" i="0" lang="pt-BR">
                           <a:solidFill>
-                            <a:srgbClr val="9C3103"/>
+                            <a:srgbClr val="AB521C"/>
                           </a:solidFill>
                           <a:latin typeface="Arial"/>
                         </a:rPr>
@@ -5461,7 +5461,7 @@
                       </a:solidFill>
                     </a:lnB>
                     <a:solidFill>
-                      <a:srgbClr val="FFD8B5"/>
+                      <a:srgbClr val="F6D9C9"/>
                     </a:solidFill>
                   </a:tcPr>
                 </a:tc>
@@ -5474,7 +5474,7 @@
                       <a:r>
                         <a:rPr sz="800" b="1" i="0" lang="pt-BR">
                           <a:solidFill>
-                            <a:srgbClr val="9C3A02"/>
+                            <a:srgbClr val="AA5917"/>
                           </a:solidFill>
                           <a:latin typeface="Arial"/>
                         </a:rPr>
@@ -5502,7 +5502,7 @@
                       </a:solidFill>
                     </a:lnB>
                     <a:solidFill>
-                      <a:srgbClr val="FFDBB1"/>
+                      <a:srgbClr val="F6DCC8"/>
                     </a:solidFill>
                   </a:tcPr>
                 </a:tc>
@@ -5515,7 +5515,7 @@
                       <a:r>
                         <a:rPr sz="800" b="1" i="0" lang="pt-BR">
                           <a:solidFill>
-                            <a:srgbClr val="9C4301"/>
+                            <a:srgbClr val="A96012"/>
                           </a:solidFill>
                           <a:latin typeface="Arial"/>
                         </a:rPr>
@@ -5543,7 +5543,7 @@
                       </a:solidFill>
                     </a:lnB>
                     <a:solidFill>
-                      <a:srgbClr val="FFDFAC"/>
+                      <a:srgbClr val="F6DFC8"/>
                     </a:solidFill>
                   </a:tcPr>
                 </a:tc>
@@ -5556,7 +5556,7 @@
                       <a:r>
                         <a:rPr sz="800" b="1" i="0" lang="pt-BR">
                           <a:solidFill>
-                            <a:srgbClr val="756400"/>
+                            <a:srgbClr val="887C0C"/>
                           </a:solidFill>
                           <a:latin typeface="Arial"/>
                         </a:rPr>
@@ -5584,7 +5584,7 @@
                       </a:solidFill>
                     </a:lnB>
                     <a:solidFill>
-                      <a:srgbClr val="F1EBA8"/>
+                      <a:srgbClr val="EEE9C9"/>
                     </a:solidFill>
                   </a:tcPr>
                 </a:tc>
@@ -5597,7 +5597,7 @@
                       <a:r>
                         <a:rPr sz="800" b="1" i="0" lang="pt-BR">
                           <a:solidFill>
-                            <a:srgbClr val="006100"/>
+                            <a:srgbClr val="2E7D32"/>
                           </a:solidFill>
                           <a:latin typeface="Arial"/>
                         </a:rPr>
@@ -5625,7 +5625,7 @@
                       </a:solidFill>
                     </a:lnB>
                     <a:solidFill>
-                      <a:srgbClr val="C6EFCE"/>
+                      <a:srgbClr val="D4E9D1"/>
                     </a:solidFill>
                   </a:tcPr>
                 </a:tc>
@@ -5642,14 +5642,14 @@
         </p:nvSpPr>
         <p:spPr>
           <a:xfrm>
-            <a:off x="438912" y="2762178"/>
-            <a:ext cx="118872" cy="73700"/>
+            <a:off x="438912" y="2745353"/>
+            <a:ext cx="155448" cy="96377"/>
           </a:xfrm>
           <a:prstGeom prst="rect">
             <a:avLst/>
           </a:prstGeom>
           <a:noFill/>
-          <a:ln w="8255" cap="rnd">
+          <a:ln w="10795" cap="rnd">
             <a:solidFill>
               <a:srgbClr val="1A1A1A"/>
             </a:solidFill>
@@ -5673,8 +5673,8 @@
         </p:nvSpPr>
         <p:spPr>
           <a:xfrm>
-            <a:off x="454365" y="2778820"/>
-            <a:ext cx="52303" cy="7726"/>
+            <a:off x="459120" y="2767116"/>
+            <a:ext cx="68397" cy="10104"/>
           </a:xfrm>
           <a:prstGeom prst="rect">
             <a:avLst/>
@@ -5703,8 +5703,8 @@
         </p:nvSpPr>
         <p:spPr>
           <a:xfrm>
-            <a:off x="454365" y="2794274"/>
-            <a:ext cx="87965" cy="7726"/>
+            <a:off x="459120" y="2787324"/>
+            <a:ext cx="115031" cy="10104"/>
           </a:xfrm>
           <a:prstGeom prst="rect">
             <a:avLst/>
@@ -5733,8 +5733,8 @@
         </p:nvSpPr>
         <p:spPr>
           <a:xfrm>
-            <a:off x="454365" y="2809727"/>
-            <a:ext cx="39227" cy="7726"/>
+            <a:off x="459120" y="2807533"/>
+            <a:ext cx="51297" cy="10104"/>
           </a:xfrm>
           <a:prstGeom prst="rect">
             <a:avLst/>
@@ -5763,8 +5763,8 @@
         </p:nvSpPr>
         <p:spPr>
           <a:xfrm>
-            <a:off x="490026" y="2835879"/>
-            <a:ext cx="16642" cy="21396"/>
+            <a:off x="505754" y="2841731"/>
+            <a:ext cx="21762" cy="27980"/>
           </a:xfrm>
           <a:prstGeom prst="rect">
             <a:avLst/>
@@ -5793,8 +5793,8 @@
         </p:nvSpPr>
         <p:spPr>
           <a:xfrm>
-            <a:off x="467441" y="2857276"/>
-            <a:ext cx="61813" cy="10698"/>
+            <a:off x="476219" y="2869712"/>
+            <a:ext cx="80832" cy="13990"/>
           </a:xfrm>
           <a:prstGeom prst="rect">
             <a:avLst/>
@@ -5817,16 +5817,16 @@
       </p:sp>
       <p:sp>
         <p:nvSpPr>
-          <p:cNvPr id="30" name="Gear 9 29"/>
+          <p:cNvPr id="30" name="Oval 29"/>
           <p:cNvSpPr/>
           <p:nvPr/>
         </p:nvSpPr>
         <p:spPr>
           <a:xfrm>
-            <a:off x="438912" y="3242818"/>
-            <a:ext cx="118872" cy="118872"/>
+            <a:off x="438912" y="3224530"/>
+            <a:ext cx="155448" cy="155448"/>
           </a:xfrm>
-          <a:prstGeom prst="gear9">
+          <a:prstGeom prst="ellipse">
             <a:avLst/>
           </a:prstGeom>
           <a:solidFill>
@@ -5838,7 +5838,7 @@
           <a:effectLst/>
         </p:spPr>
         <p:txBody>
-          <a:bodyPr rtlCol="0" anchor="ctr" wrap="square"/>
+          <a:bodyPr rtlCol="0" anchor="ctr" lIns="0" rIns="0" tIns="0" bIns="0"/>
           <a:lstStyle/>
           <a:p>
             <a:pPr algn="ctr"/>
@@ -5847,14 +5847,136 @@
       </p:sp>
       <p:sp>
         <p:nvSpPr>
-          <p:cNvPr id="31" name="Oval 30"/>
+          <p:cNvPr id="31" name="Rounded Rectangle 30"/>
           <p:cNvSpPr/>
           <p:nvPr/>
         </p:nvSpPr>
         <p:spPr>
           <a:xfrm>
-            <a:off x="477545" y="3281451"/>
-            <a:ext cx="41605" cy="41605"/>
+            <a:off x="476219" y="3254376"/>
+            <a:ext cx="80832" cy="66283"/>
+          </a:xfrm>
+          <a:prstGeom prst="roundRect">
+            <a:avLst>
+              <a:gd name="adj" fmla="val 35000"/>
+            </a:avLst>
+          </a:prstGeom>
+          <a:solidFill>
+            <a:srgbClr val="FFFFFF"/>
+          </a:solidFill>
+          <a:ln>
+            <a:noFill/>
+          </a:ln>
+          <a:effectLst/>
+        </p:spPr>
+        <p:txBody>
+          <a:bodyPr rtlCol="0" anchor="ctr" lIns="0" rIns="0" tIns="0" bIns="0"/>
+          <a:lstStyle/>
+          <a:p>
+            <a:pPr algn="ctr"/>
+          </a:p>
+        </p:txBody>
+      </p:sp>
+      <p:sp>
+        <p:nvSpPr>
+          <p:cNvPr id="32" name="Oval 31"/>
+          <p:cNvSpPr/>
+          <p:nvPr/>
+        </p:nvSpPr>
+        <p:spPr>
+          <a:xfrm>
+            <a:off x="485515" y="3276605"/>
+            <a:ext cx="20208" cy="20208"/>
+          </a:xfrm>
+          <a:prstGeom prst="ellipse">
+            <a:avLst/>
+          </a:prstGeom>
+          <a:solidFill>
+            <a:srgbClr val="2F5BA8"/>
+          </a:solidFill>
+          <a:ln>
+            <a:noFill/>
+          </a:ln>
+          <a:effectLst/>
+        </p:spPr>
+        <p:txBody>
+          <a:bodyPr rtlCol="0" anchor="ctr" lIns="0" rIns="0" tIns="0" bIns="0"/>
+          <a:lstStyle/>
+          <a:p>
+            <a:pPr algn="ctr"/>
+          </a:p>
+        </p:txBody>
+      </p:sp>
+      <p:sp>
+        <p:nvSpPr>
+          <p:cNvPr id="33" name="Oval 32"/>
+          <p:cNvSpPr/>
+          <p:nvPr/>
+        </p:nvSpPr>
+        <p:spPr>
+          <a:xfrm>
+            <a:off x="527548" y="3276605"/>
+            <a:ext cx="20208" cy="20208"/>
+          </a:xfrm>
+          <a:prstGeom prst="ellipse">
+            <a:avLst/>
+          </a:prstGeom>
+          <a:solidFill>
+            <a:srgbClr val="2F5BA8"/>
+          </a:solidFill>
+          <a:ln>
+            <a:noFill/>
+          </a:ln>
+          <a:effectLst/>
+        </p:spPr>
+        <p:txBody>
+          <a:bodyPr rtlCol="0" anchor="ctr" lIns="0" rIns="0" tIns="0" bIns="0"/>
+          <a:lstStyle/>
+          <a:p>
+            <a:pPr algn="ctr"/>
+          </a:p>
+        </p:txBody>
+      </p:sp>
+      <p:sp>
+        <p:nvSpPr>
+          <p:cNvPr id="34" name="Rectangle 33"/>
+          <p:cNvSpPr/>
+          <p:nvPr/>
+        </p:nvSpPr>
+        <p:spPr>
+          <a:xfrm>
+            <a:off x="511195" y="3233856"/>
+            <a:ext cx="10881" cy="20208"/>
+          </a:xfrm>
+          <a:prstGeom prst="rect">
+            <a:avLst/>
+          </a:prstGeom>
+          <a:solidFill>
+            <a:srgbClr val="FFFFFF"/>
+          </a:solidFill>
+          <a:ln>
+            <a:noFill/>
+          </a:ln>
+          <a:effectLst/>
+        </p:spPr>
+        <p:txBody>
+          <a:bodyPr rtlCol="0" anchor="ctr" lIns="0" rIns="0" tIns="0" bIns="0"/>
+          <a:lstStyle/>
+          <a:p>
+            <a:pPr algn="ctr"/>
+          </a:p>
+        </p:txBody>
+      </p:sp>
+      <p:sp>
+        <p:nvSpPr>
+          <p:cNvPr id="35" name="Oval 34"/>
+          <p:cNvSpPr/>
+          <p:nvPr/>
+        </p:nvSpPr>
+        <p:spPr>
+          <a:xfrm>
+            <a:off x="507309" y="3226861"/>
+            <a:ext cx="18653" cy="18653"/>
           </a:xfrm>
           <a:prstGeom prst="ellipse">
             <a:avLst/>
@@ -5868,7 +5990,7 @@
           <a:effectLst/>
         </p:spPr>
         <p:txBody>
-          <a:bodyPr rtlCol="0" anchor="ctr" wrap="square"/>
+          <a:bodyPr rtlCol="0" anchor="ctr" lIns="0" rIns="0" tIns="0" bIns="0"/>
           <a:lstStyle/>
           <a:p>
             <a:pPr algn="ctr"/>
@@ -5877,74 +5999,14 @@
       </p:sp>
       <p:sp>
         <p:nvSpPr>
-          <p:cNvPr id="32" name="Rectangle 31"/>
+          <p:cNvPr id="36" name="Oval 35"/>
           <p:cNvSpPr/>
           <p:nvPr/>
         </p:nvSpPr>
         <p:spPr>
-          <a:xfrm rot="20006097">
-            <a:off x="451831" y="3762982"/>
-            <a:ext cx="93032" cy="7726"/>
-          </a:xfrm>
-          <a:prstGeom prst="rect">
-            <a:avLst/>
-          </a:prstGeom>
-          <a:solidFill>
-            <a:srgbClr val="2F5BA8"/>
-          </a:solidFill>
-          <a:ln>
-            <a:noFill/>
-          </a:ln>
-          <a:effectLst/>
-        </p:spPr>
-        <p:txBody>
-          <a:bodyPr rtlCol="0" anchor="ctr" wrap="square"/>
-          <a:lstStyle/>
-          <a:p>
-            <a:pPr algn="ctr"/>
-          </a:p>
-        </p:txBody>
-      </p:sp>
-      <p:sp>
-        <p:nvSpPr>
-          <p:cNvPr id="33" name="Rectangle 32"/>
-          <p:cNvSpPr/>
-          <p:nvPr/>
-        </p:nvSpPr>
-        <p:spPr>
-          <a:xfrm rot="1593903">
-            <a:off x="451831" y="3804587"/>
-            <a:ext cx="93032" cy="7726"/>
-          </a:xfrm>
-          <a:prstGeom prst="rect">
-            <a:avLst/>
-          </a:prstGeom>
-          <a:solidFill>
-            <a:srgbClr val="2F5BA8"/>
-          </a:solidFill>
-          <a:ln>
-            <a:noFill/>
-          </a:ln>
-          <a:effectLst/>
-        </p:spPr>
-        <p:txBody>
-          <a:bodyPr rtlCol="0" anchor="ctr" wrap="square"/>
-          <a:lstStyle/>
-          <a:p>
-            <a:pPr algn="ctr"/>
-          </a:p>
-        </p:txBody>
-      </p:sp>
-      <p:sp>
-        <p:nvSpPr>
-          <p:cNvPr id="34" name="Oval 33"/>
-          <p:cNvSpPr/>
-          <p:nvPr/>
-        </p:nvSpPr>
-        <p:spPr>
           <a:xfrm>
-            <a:off x="438912" y="3769817"/>
-            <a:ext cx="35661" cy="35661"/>
+            <a:off x="438912" y="3709924"/>
+            <a:ext cx="155448" cy="155448"/>
           </a:xfrm>
           <a:prstGeom prst="ellipse">
             <a:avLst/>
@@ -5958,7 +6020,7 @@
           <a:effectLst/>
         </p:spPr>
         <p:txBody>
-          <a:bodyPr rtlCol="0" anchor="ctr" wrap="square"/>
+          <a:bodyPr rtlCol="0" anchor="ctr" lIns="0" rIns="0" tIns="0" bIns="0"/>
           <a:lstStyle/>
           <a:p>
             <a:pPr algn="ctr"/>
@@ -5967,14 +6029,94 @@
       </p:sp>
       <p:sp>
         <p:nvSpPr>
-          <p:cNvPr id="35" name="Oval 34"/>
+          <p:cNvPr id="37" name="Rounded Rectangle 36"/>
           <p:cNvSpPr/>
           <p:nvPr/>
         </p:nvSpPr>
         <p:spPr>
           <a:xfrm>
-            <a:off x="522122" y="3728212"/>
-            <a:ext cx="35661" cy="35661"/>
+            <a:off x="470001" y="3741262"/>
+            <a:ext cx="93268" cy="68397"/>
+          </a:xfrm>
+          <a:prstGeom prst="roundRect">
+            <a:avLst>
+              <a:gd name="adj" fmla="val 35000"/>
+            </a:avLst>
+          </a:prstGeom>
+          <a:solidFill>
+            <a:srgbClr val="FFFFFF"/>
+          </a:solidFill>
+          <a:ln>
+            <a:noFill/>
+          </a:ln>
+          <a:effectLst/>
+        </p:spPr>
+        <p:txBody>
+          <a:bodyPr rtlCol="0" anchor="ctr" lIns="0" rIns="0" tIns="0" bIns="0"/>
+          <a:lstStyle/>
+          <a:p>
+            <a:pPr algn="ctr"/>
+          </a:p>
+        </p:txBody>
+      </p:sp>
+      <p:sp>
+        <p:nvSpPr>
+          <p:cNvPr id="38" name="Freeform 37"/>
+          <p:cNvSpPr/>
+          <p:nvPr/>
+        </p:nvSpPr>
+        <p:spPr>
+          <a:xfrm>
+            <a:off x="479328" y="3808104"/>
+            <a:ext cx="24250" cy="23318"/>
+          </a:xfrm>
+          <a:custGeom>
+            <a:avLst/>
+            <a:gdLst/>
+            <a:ahLst/>
+            <a:cxnLst/>
+            <a:rect l="l" t="t" r="r" b="b"/>
+            <a:pathLst>
+              <a:path w="24250" h="23318">
+                <a:moveTo>
+                  <a:pt x="9327" y="0"/>
+                </a:moveTo>
+                <a:lnTo>
+                  <a:pt x="0" y="23318"/>
+                </a:lnTo>
+                <a:lnTo>
+                  <a:pt x="24250" y="0"/>
+                </a:lnTo>
+                <a:close/>
+              </a:path>
+            </a:pathLst>
+          </a:custGeom>
+          <a:solidFill>
+            <a:srgbClr val="FFFFFF"/>
+          </a:solidFill>
+          <a:ln>
+            <a:noFill/>
+          </a:ln>
+          <a:effectLst/>
+        </p:spPr>
+        <p:txBody>
+          <a:bodyPr rtlCol="0" anchor="ctr"/>
+          <a:lstStyle/>
+          <a:p>
+            <a:pPr algn="ctr"/>
+          </a:p>
+        </p:txBody>
+      </p:sp>
+      <p:sp>
+        <p:nvSpPr>
+          <p:cNvPr id="39" name="Oval 38"/>
+          <p:cNvSpPr/>
+          <p:nvPr/>
+        </p:nvSpPr>
+        <p:spPr>
+          <a:xfrm>
+            <a:off x="491142" y="3768621"/>
+            <a:ext cx="13679" cy="13679"/>
           </a:xfrm>
           <a:prstGeom prst="ellipse">
             <a:avLst/>
@@ -5988,7 +6130,7 @@
           <a:effectLst/>
         </p:spPr>
         <p:txBody>
-          <a:bodyPr rtlCol="0" anchor="ctr" wrap="square"/>
+          <a:bodyPr rtlCol="0" anchor="ctr" lIns="0" rIns="0" tIns="0" bIns="0"/>
           <a:lstStyle/>
           <a:p>
             <a:pPr algn="ctr"/>
@@ -5997,14 +6139,14 @@
       </p:sp>
       <p:sp>
         <p:nvSpPr>
-          <p:cNvPr id="36" name="Oval 35"/>
+          <p:cNvPr id="40" name="Oval 39"/>
           <p:cNvSpPr/>
           <p:nvPr/>
         </p:nvSpPr>
         <p:spPr>
           <a:xfrm>
-            <a:off x="522122" y="3811422"/>
-            <a:ext cx="35661" cy="35661"/>
+            <a:off x="509796" y="3768621"/>
+            <a:ext cx="13679" cy="13679"/>
           </a:xfrm>
           <a:prstGeom prst="ellipse">
             <a:avLst/>
@@ -6018,7 +6160,7 @@
           <a:effectLst/>
         </p:spPr>
         <p:txBody>
-          <a:bodyPr rtlCol="0" anchor="ctr" wrap="square"/>
+          <a:bodyPr rtlCol="0" anchor="ctr" lIns="0" rIns="0" tIns="0" bIns="0"/>
           <a:lstStyle/>
           <a:p>
             <a:pPr algn="ctr"/>
@@ -6027,7 +6169,37 @@
       </p:sp>
       <p:sp>
         <p:nvSpPr>
-          <p:cNvPr id="37" name="Rounded Rectangle 36"/>
+          <p:cNvPr id="41" name="Oval 40"/>
+          <p:cNvSpPr/>
+          <p:nvPr/>
+        </p:nvSpPr>
+        <p:spPr>
+          <a:xfrm>
+            <a:off x="528450" y="3768621"/>
+            <a:ext cx="13679" cy="13679"/>
+          </a:xfrm>
+          <a:prstGeom prst="ellipse">
+            <a:avLst/>
+          </a:prstGeom>
+          <a:solidFill>
+            <a:srgbClr val="2F5BA8"/>
+          </a:solidFill>
+          <a:ln>
+            <a:noFill/>
+          </a:ln>
+          <a:effectLst/>
+        </p:spPr>
+        <p:txBody>
+          <a:bodyPr rtlCol="0" anchor="ctr" lIns="0" rIns="0" tIns="0" bIns="0"/>
+          <a:lstStyle/>
+          <a:p>
+            <a:pPr algn="ctr"/>
+          </a:p>
+        </p:txBody>
+      </p:sp>
+      <p:sp>
+        <p:nvSpPr>
+          <p:cNvPr id="42" name="Rounded Rectangle 41"/>
           <p:cNvSpPr/>
           <p:nvPr/>
         </p:nvSpPr>
@@ -6059,7 +6231,7 @@
       </p:sp>
       <p:sp>
         <p:nvSpPr>
-          <p:cNvPr id="38" name="Rectangle 37"/>
+          <p:cNvPr id="43" name="Rectangle 42"/>
           <p:cNvSpPr/>
           <p:nvPr/>
         </p:nvSpPr>
@@ -6089,7 +6261,7 @@
       </p:sp>
       <p:sp>
         <p:nvSpPr>
-          <p:cNvPr id="39" name="Rectangle 38"/>
+          <p:cNvPr id="44" name="Rectangle 43"/>
           <p:cNvSpPr/>
           <p:nvPr/>
         </p:nvSpPr>
@@ -6119,7 +6291,7 @@
       </p:sp>
       <p:sp>
         <p:nvSpPr>
-          <p:cNvPr id="40" name="Rectangle 39"/>
+          <p:cNvPr id="45" name="Rectangle 44"/>
           <p:cNvSpPr/>
           <p:nvPr/>
         </p:nvSpPr>
@@ -6149,7 +6321,7 @@
       </p:sp>
       <p:sp>
         <p:nvSpPr>
-          <p:cNvPr id="41" name="TextBox 40"/>
+          <p:cNvPr id="46" name="TextBox 45"/>
           <p:cNvSpPr txBox="1"/>
           <p:nvPr/>
         </p:nvSpPr>
@@ -6184,7 +6356,7 @@
       </p:sp>
       <p:sp>
         <p:nvSpPr>
-          <p:cNvPr id="42" name="TextBox 41"/>
+          <p:cNvPr id="47" name="TextBox 46"/>
           <p:cNvSpPr txBox="1"/>
           <p:nvPr/>
         </p:nvSpPr>
@@ -6219,7 +6391,7 @@
       </p:sp>
       <p:graphicFrame>
         <p:nvGraphicFramePr>
-          <p:cNvPr id="43" name="Table 42"/>
+          <p:cNvPr id="48" name="Table 47"/>
           <p:cNvGraphicFramePr>
             <a:graphicFrameLocks noGrp="1"/>
           </p:cNvGraphicFramePr>
@@ -6592,7 +6764,7 @@
                       </a:r>
                     </a:p>
                   </a:txBody>
-                  <a:tcPr marL="219456" marR="219456" marT="36576" marB="36576" anchor="ctr">
+                  <a:tcPr marL="256032" marR="256032" marT="36576" marB="36576" anchor="ctr">
                     <a:lnL w="6350" cap="flat" cmpd="sng" algn="ctr">
                       <a:noFill/>
                     </a:lnL>
@@ -6880,7 +7052,7 @@
                       <a:r>
                         <a:rPr sz="800" b="1" i="0" lang="pt-BR">
                           <a:solidFill>
-                            <a:srgbClr val="9C0006"/>
+                            <a:srgbClr val="B02A37"/>
                           </a:solidFill>
                           <a:latin typeface="Arial"/>
                         </a:rPr>
@@ -6908,7 +7080,7 @@
                       </a:solidFill>
                     </a:lnB>
                     <a:solidFill>
-                      <a:srgbClr val="FFC7CE"/>
+                      <a:srgbClr val="F6C9CB"/>
                     </a:solidFill>
                   </a:tcPr>
                 </a:tc>
@@ -6954,7 +7126,7 @@
                       </a:r>
                     </a:p>
                   </a:txBody>
-                  <a:tcPr marL="219456" marR="219456" marT="36576" marB="36576" anchor="ctr">
+                  <a:tcPr marL="256032" marR="256032" marT="36576" marB="36576" anchor="ctr">
                     <a:lnL w="6350" cap="flat" cmpd="sng" algn="ctr">
                       <a:noFill/>
                     </a:lnL>
@@ -7242,7 +7414,7 @@
                       <a:r>
                         <a:rPr sz="800" b="1" i="0" lang="pt-BR">
                           <a:solidFill>
-                            <a:srgbClr val="9C0006"/>
+                            <a:srgbClr val="B02A37"/>
                           </a:solidFill>
                           <a:latin typeface="Arial"/>
                         </a:rPr>
@@ -7270,7 +7442,7 @@
                       </a:solidFill>
                     </a:lnB>
                     <a:solidFill>
-                      <a:srgbClr val="FFC7CE"/>
+                      <a:srgbClr val="F6C9CB"/>
                     </a:solidFill>
                   </a:tcPr>
                 </a:tc>
@@ -7281,24 +7453,23 @@
       </p:graphicFrame>
       <p:sp>
         <p:nvSpPr>
-          <p:cNvPr id="44" name="Oval 43"/>
+          <p:cNvPr id="49" name="Oval 48"/>
           <p:cNvSpPr/>
           <p:nvPr/>
         </p:nvSpPr>
         <p:spPr>
           <a:xfrm>
-            <a:off x="441907" y="5156851"/>
-            <a:ext cx="27958" cy="27958"/>
+            <a:off x="442829" y="5152089"/>
+            <a:ext cx="36561" cy="36561"/>
           </a:xfrm>
           <a:prstGeom prst="ellipse">
             <a:avLst/>
           </a:prstGeom>
-          <a:noFill/>
-          <a:ln w="7594" cap="rnd">
-            <a:solidFill>
-              <a:srgbClr val="E06C3C"/>
-            </a:solidFill>
-            <a:round/>
+          <a:solidFill>
+            <a:srgbClr val="E06C3C"/>
+          </a:solidFill>
+          <a:ln>
+            <a:noFill/>
           </a:ln>
           <a:effectLst/>
         </p:spPr>
@@ -7312,14 +7483,14 @@
       </p:sp>
       <p:sp>
         <p:nvSpPr>
-          <p:cNvPr id="45" name="Round Same Side Corner Rectangle 44"/>
+          <p:cNvPr id="50" name="Round Same Side Corner Rectangle 49"/>
           <p:cNvSpPr/>
           <p:nvPr/>
         </p:nvSpPr>
         <p:spPr>
           <a:xfrm>
-            <a:off x="438912" y="5183027"/>
-            <a:ext cx="33949" cy="39940"/>
+            <a:off x="438912" y="5186319"/>
+            <a:ext cx="44395" cy="52230"/>
           </a:xfrm>
           <a:prstGeom prst="round2SameRect">
             <a:avLst>
@@ -7327,12 +7498,11 @@
               <a:gd name="adj2" fmla="val 0"/>
             </a:avLst>
           </a:prstGeom>
-          <a:noFill/>
-          <a:ln w="7594" cap="rnd">
-            <a:solidFill>
-              <a:srgbClr val="E06C3C"/>
-            </a:solidFill>
-            <a:round/>
+          <a:solidFill>
+            <a:srgbClr val="E06C3C"/>
+          </a:solidFill>
+          <a:ln>
+            <a:noFill/>
           </a:ln>
           <a:effectLst/>
         </p:spPr>
@@ -7346,24 +7516,23 @@
       </p:sp>
       <p:sp>
         <p:nvSpPr>
-          <p:cNvPr id="46" name="Oval 45"/>
+          <p:cNvPr id="51" name="Oval 50"/>
           <p:cNvSpPr/>
           <p:nvPr/>
         </p:nvSpPr>
         <p:spPr>
           <a:xfrm>
-            <a:off x="520363" y="5156851"/>
-            <a:ext cx="27958" cy="27958"/>
+            <a:off x="545424" y="5152089"/>
+            <a:ext cx="36561" cy="36561"/>
           </a:xfrm>
           <a:prstGeom prst="ellipse">
             <a:avLst/>
           </a:prstGeom>
-          <a:noFill/>
-          <a:ln w="7594" cap="rnd">
-            <a:solidFill>
-              <a:srgbClr val="E06C3C"/>
-            </a:solidFill>
-            <a:round/>
+          <a:solidFill>
+            <a:srgbClr val="E06C3C"/>
+          </a:solidFill>
+          <a:ln>
+            <a:noFill/>
           </a:ln>
           <a:effectLst/>
         </p:spPr>
@@ -7377,14 +7546,14 @@
       </p:sp>
       <p:sp>
         <p:nvSpPr>
-          <p:cNvPr id="47" name="Round Same Side Corner Rectangle 46"/>
+          <p:cNvPr id="52" name="Round Same Side Corner Rectangle 51"/>
           <p:cNvSpPr/>
           <p:nvPr/>
         </p:nvSpPr>
         <p:spPr>
           <a:xfrm>
-            <a:off x="517367" y="5183027"/>
-            <a:ext cx="33949" cy="39940"/>
+            <a:off x="541507" y="5186319"/>
+            <a:ext cx="44395" cy="52230"/>
           </a:xfrm>
           <a:prstGeom prst="round2SameRect">
             <a:avLst>
@@ -7392,12 +7561,11 @@
               <a:gd name="adj2" fmla="val 0"/>
             </a:avLst>
           </a:prstGeom>
-          <a:noFill/>
-          <a:ln w="7594" cap="rnd">
-            <a:solidFill>
-              <a:srgbClr val="E06C3C"/>
-            </a:solidFill>
-            <a:round/>
+          <a:solidFill>
+            <a:srgbClr val="E06C3C"/>
+          </a:solidFill>
+          <a:ln>
+            <a:noFill/>
           </a:ln>
           <a:effectLst/>
         </p:spPr>
@@ -7411,14 +7579,14 @@
       </p:sp>
       <p:sp>
         <p:nvSpPr>
-          <p:cNvPr id="48" name="Round Same Side Corner Rectangle 47"/>
+          <p:cNvPr id="53" name="Round Same Side Corner Rectangle 52"/>
           <p:cNvSpPr/>
           <p:nvPr/>
         </p:nvSpPr>
         <p:spPr>
           <a:xfrm>
-            <a:off x="473979" y="5170545"/>
-            <a:ext cx="48737" cy="55869"/>
+            <a:off x="483214" y="5168442"/>
+            <a:ext cx="66842" cy="76169"/>
           </a:xfrm>
           <a:prstGeom prst="round2SameRect">
             <a:avLst>
@@ -7444,14 +7612,14 @@
       </p:sp>
       <p:sp>
         <p:nvSpPr>
-          <p:cNvPr id="49" name="Oval 48"/>
+          <p:cNvPr id="54" name="Oval 53"/>
           <p:cNvSpPr/>
           <p:nvPr/>
         </p:nvSpPr>
         <p:spPr>
           <a:xfrm>
-            <a:off x="477545" y="5139044"/>
-            <a:ext cx="41605" cy="41605"/>
+            <a:off x="487878" y="5127249"/>
+            <a:ext cx="57515" cy="57515"/>
           </a:xfrm>
           <a:prstGeom prst="ellipse">
             <a:avLst/>
@@ -7474,24 +7642,23 @@
       </p:sp>
       <p:sp>
         <p:nvSpPr>
-          <p:cNvPr id="50" name="Oval 49"/>
+          <p:cNvPr id="55" name="Oval 54"/>
           <p:cNvSpPr/>
           <p:nvPr/>
         </p:nvSpPr>
         <p:spPr>
           <a:xfrm>
-            <a:off x="481705" y="5143205"/>
-            <a:ext cx="33284" cy="33284"/>
+            <a:off x="494873" y="5134244"/>
+            <a:ext cx="43525" cy="43525"/>
           </a:xfrm>
           <a:prstGeom prst="ellipse">
             <a:avLst/>
           </a:prstGeom>
-          <a:noFill/>
-          <a:ln w="7594" cap="rnd">
-            <a:solidFill>
-              <a:srgbClr val="E06C3C"/>
-            </a:solidFill>
-            <a:round/>
+          <a:solidFill>
+            <a:srgbClr val="E06C3C"/>
+          </a:solidFill>
+          <a:ln>
+            <a:noFill/>
           </a:ln>
           <a:effectLst/>
         </p:spPr>
@@ -7505,14 +7672,14 @@
       </p:sp>
       <p:sp>
         <p:nvSpPr>
-          <p:cNvPr id="51" name="Round Same Side Corner Rectangle 50"/>
+          <p:cNvPr id="56" name="Round Same Side Corner Rectangle 55"/>
           <p:cNvSpPr/>
           <p:nvPr/>
         </p:nvSpPr>
         <p:spPr>
           <a:xfrm>
-            <a:off x="478139" y="5174706"/>
-            <a:ext cx="40416" cy="47548"/>
+            <a:off x="490209" y="5175437"/>
+            <a:ext cx="52852" cy="62179"/>
           </a:xfrm>
           <a:prstGeom prst="round2SameRect">
             <a:avLst>
@@ -7520,12 +7687,11 @@
               <a:gd name="adj2" fmla="val 0"/>
             </a:avLst>
           </a:prstGeom>
-          <a:noFill/>
-          <a:ln w="7594" cap="rnd">
-            <a:solidFill>
-              <a:srgbClr val="E06C3C"/>
-            </a:solidFill>
-            <a:round/>
+          <a:solidFill>
+            <a:srgbClr val="E06C3C"/>
+          </a:solidFill>
+          <a:ln>
+            <a:noFill/>
           </a:ln>
           <a:effectLst/>
         </p:spPr>
@@ -7539,14 +7705,14 @@
       </p:sp>
       <p:sp>
         <p:nvSpPr>
-          <p:cNvPr id="52" name="Donut 51"/>
+          <p:cNvPr id="57" name="Donut 56"/>
           <p:cNvSpPr/>
           <p:nvPr/>
         </p:nvSpPr>
         <p:spPr>
           <a:xfrm>
-            <a:off x="438912" y="5598287"/>
-            <a:ext cx="118872" cy="118872"/>
+            <a:off x="438912" y="5579999"/>
+            <a:ext cx="155448" cy="155448"/>
           </a:xfrm>
           <a:prstGeom prst="donut">
             <a:avLst>
@@ -7571,14 +7737,14 @@
       </p:sp>
       <p:sp>
         <p:nvSpPr>
-          <p:cNvPr id="53" name="Donut 52"/>
+          <p:cNvPr id="58" name="Donut 57"/>
           <p:cNvSpPr/>
           <p:nvPr/>
         </p:nvSpPr>
         <p:spPr>
           <a:xfrm>
-            <a:off x="468629" y="5628005"/>
-            <a:ext cx="59436" cy="59436"/>
+            <a:off x="477773" y="5618861"/>
+            <a:ext cx="77724" cy="77724"/>
           </a:xfrm>
           <a:prstGeom prst="donut">
             <a:avLst>
@@ -7603,14 +7769,14 @@
       </p:sp>
       <p:sp>
         <p:nvSpPr>
-          <p:cNvPr id="54" name="Oval 53"/>
+          <p:cNvPr id="59" name="Oval 58"/>
           <p:cNvSpPr/>
           <p:nvPr/>
         </p:nvSpPr>
         <p:spPr>
           <a:xfrm>
-            <a:off x="486460" y="5645835"/>
-            <a:ext cx="23774" cy="23774"/>
+            <a:off x="501091" y="5642178"/>
+            <a:ext cx="31089" cy="31089"/>
           </a:xfrm>
           <a:prstGeom prst="ellipse">
             <a:avLst/>
@@ -7633,7 +7799,7 @@
       </p:sp>
       <p:sp>
         <p:nvSpPr>
-          <p:cNvPr id="55" name="TextBox 54"/>
+          <p:cNvPr id="60" name="TextBox 59"/>
           <p:cNvSpPr txBox="1"/>
           <p:nvPr/>
         </p:nvSpPr>
@@ -7668,7 +7834,7 @@
       </p:sp>
       <p:graphicFrame>
         <p:nvGraphicFramePr>
-          <p:cNvPr id="56" name="Table 55"/>
+          <p:cNvPr id="61" name="Table 60"/>
           <p:cNvGraphicFramePr>
             <a:graphicFrameLocks noGrp="1"/>
           </p:cNvGraphicFramePr>
@@ -7730,7 +7896,7 @@
       </p:graphicFrame>
       <p:sp>
         <p:nvSpPr>
-          <p:cNvPr id="57" name="Oval 56"/>
+          <p:cNvPr id="62" name="Oval 61"/>
           <p:cNvSpPr/>
           <p:nvPr/>
         </p:nvSpPr>
@@ -7760,7 +7926,7 @@
       </p:sp>
       <p:sp>
         <p:nvSpPr>
-          <p:cNvPr id="58" name="Rectangle 57"/>
+          <p:cNvPr id="63" name="Rectangle 62"/>
           <p:cNvSpPr/>
           <p:nvPr/>
         </p:nvSpPr>
@@ -7790,7 +7956,7 @@
       </p:sp>
       <p:sp>
         <p:nvSpPr>
-          <p:cNvPr id="59" name="Oval 58"/>
+          <p:cNvPr id="64" name="Oval 63"/>
           <p:cNvSpPr/>
           <p:nvPr/>
         </p:nvSpPr>
@@ -7820,7 +7986,7 @@
       </p:sp>
       <p:sp>
         <p:nvSpPr>
-          <p:cNvPr id="60" name="Rectangle 59"/>
+          <p:cNvPr id="65" name="Rectangle 64"/>
           <p:cNvSpPr/>
           <p:nvPr/>
         </p:nvSpPr>
@@ -7850,7 +8016,7 @@
       </p:sp>
       <p:sp>
         <p:nvSpPr>
-          <p:cNvPr id="61" name="Oval 60"/>
+          <p:cNvPr id="66" name="Oval 65"/>
           <p:cNvSpPr/>
           <p:nvPr/>
         </p:nvSpPr>
@@ -7880,7 +8046,7 @@
       </p:sp>
       <p:sp>
         <p:nvSpPr>
-          <p:cNvPr id="62" name="Rectangle 61"/>
+          <p:cNvPr id="67" name="Rectangle 66"/>
           <p:cNvSpPr/>
           <p:nvPr/>
         </p:nvSpPr>
@@ -7910,7 +8076,7 @@
       </p:sp>
       <p:graphicFrame>
         <p:nvGraphicFramePr>
-          <p:cNvPr id="63" name="Table 62"/>
+          <p:cNvPr id="68" name="Table 67"/>
           <p:cNvGraphicFramePr>
             <a:graphicFrameLocks noGrp="1"/>
           </p:cNvGraphicFramePr>
@@ -10232,7 +10398,7 @@
       </p:graphicFrame>
       <p:sp>
         <p:nvSpPr>
-          <p:cNvPr id="64" name="Oval 63"/>
+          <p:cNvPr id="69" name="Oval 68"/>
           <p:cNvSpPr/>
           <p:nvPr/>
         </p:nvSpPr>
@@ -10271,7 +10437,7 @@
       </p:sp>
       <p:sp>
         <p:nvSpPr>
-          <p:cNvPr id="65" name="Oval 64"/>
+          <p:cNvPr id="70" name="Oval 69"/>
           <p:cNvSpPr/>
           <p:nvPr/>
         </p:nvSpPr>
@@ -10310,7 +10476,7 @@
       </p:sp>
       <p:sp>
         <p:nvSpPr>
-          <p:cNvPr id="66" name="Oval 65"/>
+          <p:cNvPr id="71" name="Oval 70"/>
           <p:cNvSpPr/>
           <p:nvPr/>
         </p:nvSpPr>
@@ -10349,7 +10515,7 @@
       </p:sp>
       <p:sp>
         <p:nvSpPr>
-          <p:cNvPr id="67" name="Oval 66"/>
+          <p:cNvPr id="72" name="Oval 71"/>
           <p:cNvSpPr/>
           <p:nvPr/>
         </p:nvSpPr>
@@ -10388,7 +10554,7 @@
       </p:sp>
       <p:sp>
         <p:nvSpPr>
-          <p:cNvPr id="68" name="Oval 67"/>
+          <p:cNvPr id="73" name="Oval 72"/>
           <p:cNvSpPr/>
           <p:nvPr/>
         </p:nvSpPr>

</xml_diff>